<commit_message>
Adding some slides to the presentation, uploading current state of the frame.
</commit_message>
<xml_diff>
--- a/docs/UniProject.pptx
+++ b/docs/UniProject.pptx
@@ -7,11 +7,17 @@
   <p:sldIdLst>
     <p:sldId id="256" r:id="rId2"/>
     <p:sldId id="257" r:id="rId3"/>
-    <p:sldId id="258" r:id="rId4"/>
-    <p:sldId id="259" r:id="rId5"/>
-    <p:sldId id="260" r:id="rId6"/>
-    <p:sldId id="261" r:id="rId7"/>
-    <p:sldId id="262" r:id="rId8"/>
+    <p:sldId id="264" r:id="rId4"/>
+    <p:sldId id="258" r:id="rId5"/>
+    <p:sldId id="259" r:id="rId6"/>
+    <p:sldId id="260" r:id="rId7"/>
+    <p:sldId id="261" r:id="rId8"/>
+    <p:sldId id="262" r:id="rId9"/>
+    <p:sldId id="263" r:id="rId10"/>
+    <p:sldId id="267" r:id="rId11"/>
+    <p:sldId id="265" r:id="rId12"/>
+    <p:sldId id="266" r:id="rId13"/>
+    <p:sldId id="268" r:id="rId14"/>
   </p:sldIdLst>
   <p:sldSz cx="12192000" cy="6858000"/>
   <p:notesSz cx="6858000" cy="9144000"/>
@@ -265,7 +271,7 @@
           <a:p>
             <a:fld id="{484D9DE3-5E6C-4223-B6F3-D47F9A707926}" type="datetimeFigureOut">
               <a:rPr lang="hu-HU" smtClean="0"/>
-              <a:t>2026.04.29.</a:t>
+              <a:t>2026.05.20.</a:t>
             </a:fld>
             <a:endParaRPr lang="hu-HU"/>
           </a:p>
@@ -463,7 +469,7 @@
           <a:p>
             <a:fld id="{484D9DE3-5E6C-4223-B6F3-D47F9A707926}" type="datetimeFigureOut">
               <a:rPr lang="hu-HU" smtClean="0"/>
-              <a:t>2026.04.29.</a:t>
+              <a:t>2026.05.20.</a:t>
             </a:fld>
             <a:endParaRPr lang="hu-HU"/>
           </a:p>
@@ -671,7 +677,7 @@
           <a:p>
             <a:fld id="{484D9DE3-5E6C-4223-B6F3-D47F9A707926}" type="datetimeFigureOut">
               <a:rPr lang="hu-HU" smtClean="0"/>
-              <a:t>2026.04.29.</a:t>
+              <a:t>2026.05.20.</a:t>
             </a:fld>
             <a:endParaRPr lang="hu-HU"/>
           </a:p>
@@ -869,7 +875,7 @@
           <a:p>
             <a:fld id="{484D9DE3-5E6C-4223-B6F3-D47F9A707926}" type="datetimeFigureOut">
               <a:rPr lang="hu-HU" smtClean="0"/>
-              <a:t>2026.04.29.</a:t>
+              <a:t>2026.05.20.</a:t>
             </a:fld>
             <a:endParaRPr lang="hu-HU"/>
           </a:p>
@@ -1144,7 +1150,7 @@
           <a:p>
             <a:fld id="{484D9DE3-5E6C-4223-B6F3-D47F9A707926}" type="datetimeFigureOut">
               <a:rPr lang="hu-HU" smtClean="0"/>
-              <a:t>2026.04.29.</a:t>
+              <a:t>2026.05.20.</a:t>
             </a:fld>
             <a:endParaRPr lang="hu-HU"/>
           </a:p>
@@ -1409,7 +1415,7 @@
           <a:p>
             <a:fld id="{484D9DE3-5E6C-4223-B6F3-D47F9A707926}" type="datetimeFigureOut">
               <a:rPr lang="hu-HU" smtClean="0"/>
-              <a:t>2026.04.29.</a:t>
+              <a:t>2026.05.20.</a:t>
             </a:fld>
             <a:endParaRPr lang="hu-HU"/>
           </a:p>
@@ -1821,7 +1827,7 @@
           <a:p>
             <a:fld id="{484D9DE3-5E6C-4223-B6F3-D47F9A707926}" type="datetimeFigureOut">
               <a:rPr lang="hu-HU" smtClean="0"/>
-              <a:t>2026.04.29.</a:t>
+              <a:t>2026.05.20.</a:t>
             </a:fld>
             <a:endParaRPr lang="hu-HU"/>
           </a:p>
@@ -1962,7 +1968,7 @@
           <a:p>
             <a:fld id="{484D9DE3-5E6C-4223-B6F3-D47F9A707926}" type="datetimeFigureOut">
               <a:rPr lang="hu-HU" smtClean="0"/>
-              <a:t>2026.04.29.</a:t>
+              <a:t>2026.05.20.</a:t>
             </a:fld>
             <a:endParaRPr lang="hu-HU"/>
           </a:p>
@@ -2075,7 +2081,7 @@
           <a:p>
             <a:fld id="{484D9DE3-5E6C-4223-B6F3-D47F9A707926}" type="datetimeFigureOut">
               <a:rPr lang="hu-HU" smtClean="0"/>
-              <a:t>2026.04.29.</a:t>
+              <a:t>2026.05.20.</a:t>
             </a:fld>
             <a:endParaRPr lang="hu-HU"/>
           </a:p>
@@ -2386,7 +2392,7 @@
           <a:p>
             <a:fld id="{484D9DE3-5E6C-4223-B6F3-D47F9A707926}" type="datetimeFigureOut">
               <a:rPr lang="hu-HU" smtClean="0"/>
-              <a:t>2026.04.29.</a:t>
+              <a:t>2026.05.20.</a:t>
             </a:fld>
             <a:endParaRPr lang="hu-HU"/>
           </a:p>
@@ -2674,7 +2680,7 @@
           <a:p>
             <a:fld id="{484D9DE3-5E6C-4223-B6F3-D47F9A707926}" type="datetimeFigureOut">
               <a:rPr lang="hu-HU" smtClean="0"/>
-              <a:t>2026.04.29.</a:t>
+              <a:t>2026.05.20.</a:t>
             </a:fld>
             <a:endParaRPr lang="hu-HU"/>
           </a:p>
@@ -2924,7 +2930,7 @@
           <a:p>
             <a:fld id="{484D9DE3-5E6C-4223-B6F3-D47F9A707926}" type="datetimeFigureOut">
               <a:rPr lang="hu-HU" smtClean="0"/>
-              <a:t>2026.04.29.</a:t>
+              <a:t>2026.05.20.</a:t>
             </a:fld>
             <a:endParaRPr lang="hu-HU"/>
           </a:p>
@@ -3421,6 +3427,868 @@
 </p:sld>
 </file>
 
+<file path=ppt/slides/slide10.xml><?xml version="1.0" encoding="utf-8"?>
+<p:sld xmlns:a="http://schemas.openxmlformats.org/drawingml/2006/main" xmlns:r="http://schemas.openxmlformats.org/officeDocument/2006/relationships" xmlns:p="http://schemas.openxmlformats.org/presentationml/2006/main">
+  <p:cSld>
+    <p:spTree>
+      <p:nvGrpSpPr>
+        <p:cNvPr id="1" name=""/>
+        <p:cNvGrpSpPr/>
+        <p:nvPr/>
+      </p:nvGrpSpPr>
+      <p:grpSpPr>
+        <a:xfrm>
+          <a:off x="0" y="0"/>
+          <a:ext cx="0" cy="0"/>
+          <a:chOff x="0" y="0"/>
+          <a:chExt cx="0" cy="0"/>
+        </a:xfrm>
+      </p:grpSpPr>
+      <p:sp>
+        <p:nvSpPr>
+          <p:cNvPr id="2" name="Cím 1">
+            <a:extLst>
+              <a:ext uri="{FF2B5EF4-FFF2-40B4-BE49-F238E27FC236}">
+                <a16:creationId xmlns:a16="http://schemas.microsoft.com/office/drawing/2014/main" id="{B801D771-B323-4343-9695-C6BE8B6AEA61}"/>
+              </a:ext>
+            </a:extLst>
+          </p:cNvPr>
+          <p:cNvSpPr>
+            <a:spLocks noGrp="1"/>
+          </p:cNvSpPr>
+          <p:nvPr>
+            <p:ph type="title"/>
+          </p:nvPr>
+        </p:nvSpPr>
+        <p:spPr/>
+        <p:txBody>
+          <a:bodyPr/>
+          <a:lstStyle/>
+          <a:p>
+            <a:r>
+              <a:rPr lang="hu-HU" dirty="0">
+                <a:solidFill>
+                  <a:schemeClr val="bg1"/>
+                </a:solidFill>
+                <a:latin typeface="Arial Black" panose="020B0A04020102020204" pitchFamily="34" charset="0"/>
+              </a:rPr>
+              <a:t>Adatok megtekintése</a:t>
+            </a:r>
+            <a:endParaRPr lang="hu-HU" dirty="0"/>
+          </a:p>
+        </p:txBody>
+      </p:sp>
+      <p:sp>
+        <p:nvSpPr>
+          <p:cNvPr id="3" name="Tartalom helye 2">
+            <a:extLst>
+              <a:ext uri="{FF2B5EF4-FFF2-40B4-BE49-F238E27FC236}">
+                <a16:creationId xmlns:a16="http://schemas.microsoft.com/office/drawing/2014/main" id="{E63BE610-317C-4CEC-8BEF-F4A5F164E5AA}"/>
+              </a:ext>
+            </a:extLst>
+          </p:cNvPr>
+          <p:cNvSpPr>
+            <a:spLocks noGrp="1"/>
+          </p:cNvSpPr>
+          <p:nvPr>
+            <p:ph idx="1"/>
+          </p:nvPr>
+        </p:nvSpPr>
+        <p:spPr>
+          <a:xfrm>
+            <a:off x="838200" y="1825625"/>
+            <a:ext cx="8220075" cy="4351338"/>
+          </a:xfrm>
+        </p:spPr>
+        <p:txBody>
+          <a:bodyPr/>
+          <a:lstStyle/>
+          <a:p>
+            <a:r>
+              <a:rPr lang="hu-HU" dirty="0">
+                <a:latin typeface="Arial Black" panose="020B0A04020102020204" pitchFamily="34" charset="0"/>
+              </a:rPr>
+              <a:t>OLED kijelzőn egyedi képernyők a mért értékek kijelzésére</a:t>
+            </a:r>
+          </a:p>
+        </p:txBody>
+      </p:sp>
+      <p:pic>
+        <p:nvPicPr>
+          <p:cNvPr id="5" name="Kép 4">
+            <a:extLst>
+              <a:ext uri="{FF2B5EF4-FFF2-40B4-BE49-F238E27FC236}">
+                <a16:creationId xmlns:a16="http://schemas.microsoft.com/office/drawing/2014/main" id="{90CD1825-D35C-4CF8-86DA-9F684C1FF13A}"/>
+              </a:ext>
+            </a:extLst>
+          </p:cNvPr>
+          <p:cNvPicPr>
+            <a:picLocks noChangeAspect="1"/>
+          </p:cNvPicPr>
+          <p:nvPr/>
+        </p:nvPicPr>
+        <p:blipFill>
+          <a:blip r:embed="rId2">
+            <a:extLst>
+              <a:ext uri="{28A0092B-C50C-407E-A947-70E740481C1C}">
+                <a14:useLocalDpi xmlns:a14="http://schemas.microsoft.com/office/drawing/2010/main" val="0"/>
+              </a:ext>
+            </a:extLst>
+          </a:blip>
+          <a:stretch>
+            <a:fillRect/>
+          </a:stretch>
+        </p:blipFill>
+        <p:spPr>
+          <a:xfrm>
+            <a:off x="3062793" y="3429000"/>
+            <a:ext cx="2872293" cy="1325563"/>
+          </a:xfrm>
+          <a:prstGeom prst="rect">
+            <a:avLst/>
+          </a:prstGeom>
+          <a:effectLst>
+            <a:softEdge rad="63500"/>
+          </a:effectLst>
+        </p:spPr>
+      </p:pic>
+      <p:pic>
+        <p:nvPicPr>
+          <p:cNvPr id="6" name="Kép 5">
+            <a:extLst>
+              <a:ext uri="{FF2B5EF4-FFF2-40B4-BE49-F238E27FC236}">
+                <a16:creationId xmlns:a16="http://schemas.microsoft.com/office/drawing/2014/main" id="{E2338BC7-8572-484A-9A1E-11CFFF33FCCC}"/>
+              </a:ext>
+            </a:extLst>
+          </p:cNvPr>
+          <p:cNvPicPr>
+            <a:picLocks noChangeAspect="1"/>
+          </p:cNvPicPr>
+          <p:nvPr/>
+        </p:nvPicPr>
+        <p:blipFill>
+          <a:blip r:embed="rId3">
+            <a:extLst>
+              <a:ext uri="{28A0092B-C50C-407E-A947-70E740481C1C}">
+                <a14:useLocalDpi xmlns:a14="http://schemas.microsoft.com/office/drawing/2010/main" val="0"/>
+              </a:ext>
+            </a:extLst>
+          </a:blip>
+          <a:stretch>
+            <a:fillRect/>
+          </a:stretch>
+        </p:blipFill>
+        <p:spPr>
+          <a:xfrm>
+            <a:off x="3062793" y="4693448"/>
+            <a:ext cx="2872293" cy="1325563"/>
+          </a:xfrm>
+          <a:prstGeom prst="rect">
+            <a:avLst/>
+          </a:prstGeom>
+          <a:effectLst>
+            <a:softEdge rad="63500"/>
+          </a:effectLst>
+        </p:spPr>
+      </p:pic>
+      <p:pic>
+        <p:nvPicPr>
+          <p:cNvPr id="7" name="Kép 6">
+            <a:extLst>
+              <a:ext uri="{FF2B5EF4-FFF2-40B4-BE49-F238E27FC236}">
+                <a16:creationId xmlns:a16="http://schemas.microsoft.com/office/drawing/2014/main" id="{79C91BA8-1E8D-4D74-8E5F-670B62E16811}"/>
+              </a:ext>
+            </a:extLst>
+          </p:cNvPr>
+          <p:cNvPicPr>
+            <a:picLocks noChangeAspect="1"/>
+          </p:cNvPicPr>
+          <p:nvPr/>
+        </p:nvPicPr>
+        <p:blipFill>
+          <a:blip r:embed="rId4">
+            <a:extLst>
+              <a:ext uri="{28A0092B-C50C-407E-A947-70E740481C1C}">
+                <a14:useLocalDpi xmlns:a14="http://schemas.microsoft.com/office/drawing/2010/main" val="0"/>
+              </a:ext>
+            </a:extLst>
+          </a:blip>
+          <a:stretch>
+            <a:fillRect/>
+          </a:stretch>
+        </p:blipFill>
+        <p:spPr>
+          <a:xfrm>
+            <a:off x="5931947" y="3413516"/>
+            <a:ext cx="2872293" cy="1325563"/>
+          </a:xfrm>
+          <a:prstGeom prst="rect">
+            <a:avLst/>
+          </a:prstGeom>
+          <a:effectLst>
+            <a:softEdge rad="63500"/>
+          </a:effectLst>
+        </p:spPr>
+      </p:pic>
+      <p:pic>
+        <p:nvPicPr>
+          <p:cNvPr id="8" name="Kép 7">
+            <a:extLst>
+              <a:ext uri="{FF2B5EF4-FFF2-40B4-BE49-F238E27FC236}">
+                <a16:creationId xmlns:a16="http://schemas.microsoft.com/office/drawing/2014/main" id="{75C9F142-CE02-4D1C-948A-029248BF1B42}"/>
+              </a:ext>
+            </a:extLst>
+          </p:cNvPr>
+          <p:cNvPicPr>
+            <a:picLocks noChangeAspect="1"/>
+          </p:cNvPicPr>
+          <p:nvPr/>
+        </p:nvPicPr>
+        <p:blipFill>
+          <a:blip r:embed="rId5">
+            <a:extLst>
+              <a:ext uri="{28A0092B-C50C-407E-A947-70E740481C1C}">
+                <a14:useLocalDpi xmlns:a14="http://schemas.microsoft.com/office/drawing/2010/main" val="0"/>
+              </a:ext>
+            </a:extLst>
+          </a:blip>
+          <a:stretch>
+            <a:fillRect/>
+          </a:stretch>
+        </p:blipFill>
+        <p:spPr>
+          <a:xfrm>
+            <a:off x="5931947" y="4689878"/>
+            <a:ext cx="2872293" cy="1325563"/>
+          </a:xfrm>
+          <a:prstGeom prst="rect">
+            <a:avLst/>
+          </a:prstGeom>
+          <a:effectLst>
+            <a:softEdge rad="63500"/>
+          </a:effectLst>
+        </p:spPr>
+      </p:pic>
+      <p:pic>
+        <p:nvPicPr>
+          <p:cNvPr id="9" name="Kép 8">
+            <a:extLst>
+              <a:ext uri="{FF2B5EF4-FFF2-40B4-BE49-F238E27FC236}">
+                <a16:creationId xmlns:a16="http://schemas.microsoft.com/office/drawing/2014/main" id="{60FCA0C9-B9D2-4522-A099-E68F409AFF08}"/>
+              </a:ext>
+            </a:extLst>
+          </p:cNvPr>
+          <p:cNvPicPr>
+            <a:picLocks noChangeAspect="1"/>
+          </p:cNvPicPr>
+          <p:nvPr/>
+        </p:nvPicPr>
+        <p:blipFill>
+          <a:blip r:embed="rId6">
+            <a:extLst>
+              <a:ext uri="{28A0092B-C50C-407E-A947-70E740481C1C}">
+                <a14:useLocalDpi xmlns:a14="http://schemas.microsoft.com/office/drawing/2010/main" val="0"/>
+              </a:ext>
+            </a:extLst>
+          </a:blip>
+          <a:stretch>
+            <a:fillRect/>
+          </a:stretch>
+        </p:blipFill>
+        <p:spPr>
+          <a:xfrm>
+            <a:off x="8801101" y="4107858"/>
+            <a:ext cx="2872293" cy="1325563"/>
+          </a:xfrm>
+          <a:prstGeom prst="rect">
+            <a:avLst/>
+          </a:prstGeom>
+          <a:effectLst>
+            <a:softEdge rad="63500"/>
+          </a:effectLst>
+        </p:spPr>
+      </p:pic>
+      <p:pic>
+        <p:nvPicPr>
+          <p:cNvPr id="10" name="Kép 9">
+            <a:extLst>
+              <a:ext uri="{FF2B5EF4-FFF2-40B4-BE49-F238E27FC236}">
+                <a16:creationId xmlns:a16="http://schemas.microsoft.com/office/drawing/2014/main" id="{755A2CB6-88B5-48B3-AFC7-1D9E994D21C0}"/>
+              </a:ext>
+            </a:extLst>
+          </p:cNvPr>
+          <p:cNvPicPr>
+            <a:picLocks noChangeAspect="1"/>
+          </p:cNvPicPr>
+          <p:nvPr/>
+        </p:nvPicPr>
+        <p:blipFill>
+          <a:blip r:embed="rId7">
+            <a:extLst>
+              <a:ext uri="{28A0092B-C50C-407E-A947-70E740481C1C}">
+                <a14:useLocalDpi xmlns:a14="http://schemas.microsoft.com/office/drawing/2010/main" val="0"/>
+              </a:ext>
+            </a:extLst>
+          </a:blip>
+          <a:stretch>
+            <a:fillRect/>
+          </a:stretch>
+        </p:blipFill>
+        <p:spPr>
+          <a:xfrm>
+            <a:off x="190500" y="3429000"/>
+            <a:ext cx="2872293" cy="1325563"/>
+          </a:xfrm>
+          <a:prstGeom prst="rect">
+            <a:avLst/>
+          </a:prstGeom>
+          <a:effectLst>
+            <a:softEdge rad="63500"/>
+          </a:effectLst>
+        </p:spPr>
+      </p:pic>
+      <p:pic>
+        <p:nvPicPr>
+          <p:cNvPr id="4" name="Kép 3">
+            <a:extLst>
+              <a:ext uri="{FF2B5EF4-FFF2-40B4-BE49-F238E27FC236}">
+                <a16:creationId xmlns:a16="http://schemas.microsoft.com/office/drawing/2014/main" id="{D2A29036-AF97-4727-AC0C-D2CE37367C28}"/>
+              </a:ext>
+            </a:extLst>
+          </p:cNvPr>
+          <p:cNvPicPr>
+            <a:picLocks noChangeAspect="1"/>
+          </p:cNvPicPr>
+          <p:nvPr/>
+        </p:nvPicPr>
+        <p:blipFill>
+          <a:blip r:embed="rId8">
+            <a:extLst>
+              <a:ext uri="{28A0092B-C50C-407E-A947-70E740481C1C}">
+                <a14:useLocalDpi xmlns:a14="http://schemas.microsoft.com/office/drawing/2010/main" val="0"/>
+              </a:ext>
+            </a:extLst>
+          </a:blip>
+          <a:stretch>
+            <a:fillRect/>
+          </a:stretch>
+        </p:blipFill>
+        <p:spPr>
+          <a:xfrm>
+            <a:off x="190500" y="4693447"/>
+            <a:ext cx="2872293" cy="1325563"/>
+          </a:xfrm>
+          <a:prstGeom prst="rect">
+            <a:avLst/>
+          </a:prstGeom>
+          <a:effectLst>
+            <a:softEdge rad="63500"/>
+          </a:effectLst>
+        </p:spPr>
+      </p:pic>
+    </p:spTree>
+    <p:extLst>
+      <p:ext uri="{BB962C8B-B14F-4D97-AF65-F5344CB8AC3E}">
+        <p14:creationId xmlns:p14="http://schemas.microsoft.com/office/powerpoint/2010/main" val="935078070"/>
+      </p:ext>
+    </p:extLst>
+  </p:cSld>
+  <p:clrMapOvr>
+    <a:masterClrMapping/>
+  </p:clrMapOvr>
+</p:sld>
+</file>
+
+<file path=ppt/slides/slide11.xml><?xml version="1.0" encoding="utf-8"?>
+<p:sld xmlns:a="http://schemas.openxmlformats.org/drawingml/2006/main" xmlns:r="http://schemas.openxmlformats.org/officeDocument/2006/relationships" xmlns:p="http://schemas.openxmlformats.org/presentationml/2006/main">
+  <p:cSld>
+    <p:spTree>
+      <p:nvGrpSpPr>
+        <p:cNvPr id="1" name=""/>
+        <p:cNvGrpSpPr/>
+        <p:nvPr/>
+      </p:nvGrpSpPr>
+      <p:grpSpPr>
+        <a:xfrm>
+          <a:off x="0" y="0"/>
+          <a:ext cx="0" cy="0"/>
+          <a:chOff x="0" y="0"/>
+          <a:chExt cx="0" cy="0"/>
+        </a:xfrm>
+      </p:grpSpPr>
+      <p:sp>
+        <p:nvSpPr>
+          <p:cNvPr id="2" name="Cím 1">
+            <a:extLst>
+              <a:ext uri="{FF2B5EF4-FFF2-40B4-BE49-F238E27FC236}">
+                <a16:creationId xmlns:a16="http://schemas.microsoft.com/office/drawing/2014/main" id="{06D3F82C-C220-4ABC-9B8B-68C834601544}"/>
+              </a:ext>
+            </a:extLst>
+          </p:cNvPr>
+          <p:cNvSpPr>
+            <a:spLocks noGrp="1"/>
+          </p:cNvSpPr>
+          <p:nvPr>
+            <p:ph type="title"/>
+          </p:nvPr>
+        </p:nvSpPr>
+        <p:spPr/>
+        <p:txBody>
+          <a:bodyPr/>
+          <a:lstStyle/>
+          <a:p>
+            <a:r>
+              <a:rPr lang="hu-HU" dirty="0">
+                <a:solidFill>
+                  <a:schemeClr val="bg1"/>
+                </a:solidFill>
+                <a:latin typeface="Arial Black" panose="020B0A04020102020204" pitchFamily="34" charset="0"/>
+              </a:rPr>
+              <a:t>Tartó keret tervezése</a:t>
+            </a:r>
+          </a:p>
+        </p:txBody>
+      </p:sp>
+      <p:pic>
+        <p:nvPicPr>
+          <p:cNvPr id="9" name="Tartalom helye 8">
+            <a:extLst>
+              <a:ext uri="{FF2B5EF4-FFF2-40B4-BE49-F238E27FC236}">
+                <a16:creationId xmlns:a16="http://schemas.microsoft.com/office/drawing/2014/main" id="{197BF70A-D112-4C1D-872A-68BBBF7B6C14}"/>
+              </a:ext>
+            </a:extLst>
+          </p:cNvPr>
+          <p:cNvPicPr>
+            <a:picLocks noGrp="1" noChangeAspect="1"/>
+          </p:cNvPicPr>
+          <p:nvPr>
+            <p:ph idx="1"/>
+          </p:nvPr>
+        </p:nvPicPr>
+        <p:blipFill>
+          <a:blip r:embed="rId2">
+            <a:extLst>
+              <a:ext uri="{28A0092B-C50C-407E-A947-70E740481C1C}">
+                <a14:useLocalDpi xmlns:a14="http://schemas.microsoft.com/office/drawing/2010/main" val="0"/>
+              </a:ext>
+            </a:extLst>
+          </a:blip>
+          <a:stretch>
+            <a:fillRect/>
+          </a:stretch>
+        </p:blipFill>
+        <p:spPr>
+          <a:xfrm>
+            <a:off x="695858" y="3459954"/>
+            <a:ext cx="3766658" cy="1738313"/>
+          </a:xfrm>
+          <a:effectLst>
+            <a:softEdge rad="63500"/>
+          </a:effectLst>
+        </p:spPr>
+      </p:pic>
+      <p:pic>
+        <p:nvPicPr>
+          <p:cNvPr id="10" name="Kép 9">
+            <a:extLst>
+              <a:ext uri="{FF2B5EF4-FFF2-40B4-BE49-F238E27FC236}">
+                <a16:creationId xmlns:a16="http://schemas.microsoft.com/office/drawing/2014/main" id="{5E9C758F-C587-4AB8-B688-B65AE86BDCE2}"/>
+              </a:ext>
+            </a:extLst>
+          </p:cNvPr>
+          <p:cNvPicPr>
+            <a:picLocks noChangeAspect="1"/>
+          </p:cNvPicPr>
+          <p:nvPr/>
+        </p:nvPicPr>
+        <p:blipFill>
+          <a:blip r:embed="rId3"/>
+          <a:stretch>
+            <a:fillRect/>
+          </a:stretch>
+        </p:blipFill>
+        <p:spPr>
+          <a:xfrm>
+            <a:off x="7242063" y="2348867"/>
+            <a:ext cx="4435054" cy="3955725"/>
+          </a:xfrm>
+          <a:prstGeom prst="rect">
+            <a:avLst/>
+          </a:prstGeom>
+          <a:effectLst>
+            <a:softEdge rad="63500"/>
+          </a:effectLst>
+        </p:spPr>
+      </p:pic>
+      <p:sp>
+        <p:nvSpPr>
+          <p:cNvPr id="11" name="Nyíl: jobbra mutató 10">
+            <a:extLst>
+              <a:ext uri="{FF2B5EF4-FFF2-40B4-BE49-F238E27FC236}">
+                <a16:creationId xmlns:a16="http://schemas.microsoft.com/office/drawing/2014/main" id="{B07930C4-4152-4782-8282-D40B1B07D156}"/>
+              </a:ext>
+            </a:extLst>
+          </p:cNvPr>
+          <p:cNvSpPr/>
+          <p:nvPr/>
+        </p:nvSpPr>
+        <p:spPr>
+          <a:xfrm>
+            <a:off x="5085527" y="3907629"/>
+            <a:ext cx="1533525" cy="838200"/>
+          </a:xfrm>
+          <a:prstGeom prst="rightArrow">
+            <a:avLst/>
+          </a:prstGeom>
+        </p:spPr>
+        <p:style>
+          <a:lnRef idx="2">
+            <a:schemeClr val="dk1">
+              <a:shade val="50000"/>
+            </a:schemeClr>
+          </a:lnRef>
+          <a:fillRef idx="1">
+            <a:schemeClr val="dk1"/>
+          </a:fillRef>
+          <a:effectRef idx="0">
+            <a:schemeClr val="dk1"/>
+          </a:effectRef>
+          <a:fontRef idx="minor">
+            <a:schemeClr val="lt1"/>
+          </a:fontRef>
+        </p:style>
+        <p:txBody>
+          <a:bodyPr rtlCol="0" anchor="ctr"/>
+          <a:lstStyle/>
+          <a:p>
+            <a:pPr algn="ctr"/>
+            <a:endParaRPr lang="hu-HU"/>
+          </a:p>
+        </p:txBody>
+      </p:sp>
+    </p:spTree>
+    <p:extLst>
+      <p:ext uri="{BB962C8B-B14F-4D97-AF65-F5344CB8AC3E}">
+        <p14:creationId xmlns:p14="http://schemas.microsoft.com/office/powerpoint/2010/main" val="1839507375"/>
+      </p:ext>
+    </p:extLst>
+  </p:cSld>
+  <p:clrMapOvr>
+    <a:masterClrMapping/>
+  </p:clrMapOvr>
+</p:sld>
+</file>
+
+<file path=ppt/slides/slide12.xml><?xml version="1.0" encoding="utf-8"?>
+<p:sld xmlns:a="http://schemas.openxmlformats.org/drawingml/2006/main" xmlns:r="http://schemas.openxmlformats.org/officeDocument/2006/relationships" xmlns:p="http://schemas.openxmlformats.org/presentationml/2006/main">
+  <p:cSld>
+    <p:spTree>
+      <p:nvGrpSpPr>
+        <p:cNvPr id="1" name=""/>
+        <p:cNvGrpSpPr/>
+        <p:nvPr/>
+      </p:nvGrpSpPr>
+      <p:grpSpPr>
+        <a:xfrm>
+          <a:off x="0" y="0"/>
+          <a:ext cx="0" cy="0"/>
+          <a:chOff x="0" y="0"/>
+          <a:chExt cx="0" cy="0"/>
+        </a:xfrm>
+      </p:grpSpPr>
+      <p:sp>
+        <p:nvSpPr>
+          <p:cNvPr id="2" name="Cím 1">
+            <a:extLst>
+              <a:ext uri="{FF2B5EF4-FFF2-40B4-BE49-F238E27FC236}">
+                <a16:creationId xmlns:a16="http://schemas.microsoft.com/office/drawing/2014/main" id="{05CBC14E-C2FF-4705-8C9D-EF5A9531B826}"/>
+              </a:ext>
+            </a:extLst>
+          </p:cNvPr>
+          <p:cNvSpPr>
+            <a:spLocks noGrp="1"/>
+          </p:cNvSpPr>
+          <p:nvPr>
+            <p:ph type="title"/>
+          </p:nvPr>
+        </p:nvSpPr>
+        <p:spPr/>
+        <p:txBody>
+          <a:bodyPr/>
+          <a:lstStyle/>
+          <a:p>
+            <a:r>
+              <a:rPr lang="hu-HU" dirty="0">
+                <a:solidFill>
+                  <a:schemeClr val="bg1"/>
+                </a:solidFill>
+                <a:latin typeface="Arial Black" panose="020B0A04020102020204" pitchFamily="34" charset="0"/>
+              </a:rPr>
+              <a:t>Nem megvalósult ötletek</a:t>
+            </a:r>
+          </a:p>
+        </p:txBody>
+      </p:sp>
+      <p:sp>
+        <p:nvSpPr>
+          <p:cNvPr id="3" name="Tartalom helye 2">
+            <a:extLst>
+              <a:ext uri="{FF2B5EF4-FFF2-40B4-BE49-F238E27FC236}">
+                <a16:creationId xmlns:a16="http://schemas.microsoft.com/office/drawing/2014/main" id="{6C95C0B7-E740-4287-8865-B2FD424A006F}"/>
+              </a:ext>
+            </a:extLst>
+          </p:cNvPr>
+          <p:cNvSpPr>
+            <a:spLocks noGrp="1"/>
+          </p:cNvSpPr>
+          <p:nvPr>
+            <p:ph idx="1"/>
+          </p:nvPr>
+        </p:nvSpPr>
+        <p:spPr/>
+        <p:txBody>
+          <a:bodyPr>
+            <a:normAutofit/>
+          </a:bodyPr>
+          <a:lstStyle/>
+          <a:p>
+            <a:pPr>
+              <a:spcBef>
+                <a:spcPts val="600"/>
+              </a:spcBef>
+              <a:spcAft>
+                <a:spcPts val="600"/>
+              </a:spcAft>
+            </a:pPr>
+            <a:r>
+              <a:rPr lang="hu-HU" sz="2400" b="1" dirty="0">
+                <a:latin typeface="Arial Black" panose="020B0A04020102020204" pitchFamily="34" charset="0"/>
+              </a:rPr>
+              <a:t>A keret tényleges kinyomtatása</a:t>
+            </a:r>
+          </a:p>
+          <a:p>
+            <a:pPr lvl="1">
+              <a:spcBef>
+                <a:spcPts val="600"/>
+              </a:spcBef>
+              <a:spcAft>
+                <a:spcPts val="600"/>
+              </a:spcAft>
+            </a:pPr>
+            <a:r>
+              <a:rPr lang="hu-HU" sz="2000" b="1" dirty="0">
+                <a:latin typeface="Arial Black" panose="020B0A04020102020204" pitchFamily="34" charset="0"/>
+              </a:rPr>
+              <a:t>3D nyomtatóval kinyomtatni és össze szerelni</a:t>
+            </a:r>
+          </a:p>
+          <a:p>
+            <a:pPr>
+              <a:spcBef>
+                <a:spcPts val="600"/>
+              </a:spcBef>
+              <a:spcAft>
+                <a:spcPts val="600"/>
+              </a:spcAft>
+            </a:pPr>
+            <a:r>
+              <a:rPr lang="hu-HU" sz="2400" b="1" dirty="0">
+                <a:latin typeface="Arial Black" panose="020B0A04020102020204" pitchFamily="34" charset="0"/>
+              </a:rPr>
+              <a:t>Gomb sor extra funkciókkal</a:t>
+            </a:r>
+          </a:p>
+          <a:p>
+            <a:pPr lvl="1">
+              <a:spcBef>
+                <a:spcPts val="600"/>
+              </a:spcBef>
+              <a:spcAft>
+                <a:spcPts val="600"/>
+              </a:spcAft>
+            </a:pPr>
+            <a:r>
+              <a:rPr lang="hu-HU" sz="2000" b="1" dirty="0">
+                <a:latin typeface="Arial Black" panose="020B0A04020102020204" pitchFamily="34" charset="0"/>
+              </a:rPr>
+              <a:t>Extra funkciók hozzáadása (Beállítási lehetőségek, azonnali mérés stb.)</a:t>
+            </a:r>
+          </a:p>
+          <a:p>
+            <a:pPr>
+              <a:spcBef>
+                <a:spcPts val="600"/>
+              </a:spcBef>
+              <a:spcAft>
+                <a:spcPts val="600"/>
+              </a:spcAft>
+            </a:pPr>
+            <a:r>
+              <a:rPr lang="hu-HU" sz="2400" b="1" dirty="0">
+                <a:latin typeface="Arial Black" panose="020B0A04020102020204" pitchFamily="34" charset="0"/>
+              </a:rPr>
+              <a:t>Külön webszerver</a:t>
+            </a:r>
+          </a:p>
+          <a:p>
+            <a:pPr lvl="1">
+              <a:spcBef>
+                <a:spcPts val="600"/>
+              </a:spcBef>
+              <a:spcAft>
+                <a:spcPts val="600"/>
+              </a:spcAft>
+            </a:pPr>
+            <a:r>
+              <a:rPr lang="hu-HU" sz="2000" b="1" dirty="0">
+                <a:latin typeface="Arial Black" panose="020B0A04020102020204" pitchFamily="34" charset="0"/>
+              </a:rPr>
+              <a:t>ESP32 S3 </a:t>
+            </a:r>
+            <a:r>
+              <a:rPr lang="hu-HU" sz="2000" b="1" dirty="0" err="1">
+                <a:latin typeface="Arial Black" panose="020B0A04020102020204" pitchFamily="34" charset="0"/>
+              </a:rPr>
+              <a:t>Devkit</a:t>
+            </a:r>
+            <a:r>
+              <a:rPr lang="hu-HU" sz="2000" b="1" dirty="0">
+                <a:latin typeface="Arial Black" panose="020B0A04020102020204" pitchFamily="34" charset="0"/>
+              </a:rPr>
+              <a:t> segítségével egy saját kis webszerveren futtatni a weboldalt.</a:t>
+            </a:r>
+          </a:p>
+          <a:p>
+            <a:pPr>
+              <a:spcBef>
+                <a:spcPts val="600"/>
+              </a:spcBef>
+              <a:spcAft>
+                <a:spcPts val="600"/>
+              </a:spcAft>
+            </a:pPr>
+            <a:r>
+              <a:rPr lang="hu-HU" sz="2400" b="1" dirty="0">
+                <a:latin typeface="Arial Black" panose="020B0A04020102020204" pitchFamily="34" charset="0"/>
+              </a:rPr>
+              <a:t>Adatok alapján előre jelzés</a:t>
+            </a:r>
+          </a:p>
+          <a:p>
+            <a:pPr lvl="1">
+              <a:spcBef>
+                <a:spcPts val="600"/>
+              </a:spcBef>
+              <a:spcAft>
+                <a:spcPts val="600"/>
+              </a:spcAft>
+            </a:pPr>
+            <a:endParaRPr lang="hu-HU" sz="2000" b="1" dirty="0">
+              <a:latin typeface="Arial Black" panose="020B0A04020102020204" pitchFamily="34" charset="0"/>
+            </a:endParaRPr>
+          </a:p>
+          <a:p>
+            <a:pPr marL="0" indent="0">
+              <a:spcBef>
+                <a:spcPts val="600"/>
+              </a:spcBef>
+              <a:spcAft>
+                <a:spcPts val="600"/>
+              </a:spcAft>
+              <a:buNone/>
+            </a:pPr>
+            <a:endParaRPr lang="hu-HU" sz="2400" b="1" dirty="0">
+              <a:latin typeface="Arial Black" panose="020B0A04020102020204" pitchFamily="34" charset="0"/>
+            </a:endParaRPr>
+          </a:p>
+        </p:txBody>
+      </p:sp>
+    </p:spTree>
+    <p:extLst>
+      <p:ext uri="{BB962C8B-B14F-4D97-AF65-F5344CB8AC3E}">
+        <p14:creationId xmlns:p14="http://schemas.microsoft.com/office/powerpoint/2010/main" val="3842304151"/>
+      </p:ext>
+    </p:extLst>
+  </p:cSld>
+  <p:clrMapOvr>
+    <a:masterClrMapping/>
+  </p:clrMapOvr>
+</p:sld>
+</file>
+
+<file path=ppt/slides/slide13.xml><?xml version="1.0" encoding="utf-8"?>
+<p:sld xmlns:a="http://schemas.openxmlformats.org/drawingml/2006/main" xmlns:r="http://schemas.openxmlformats.org/officeDocument/2006/relationships" xmlns:p="http://schemas.openxmlformats.org/presentationml/2006/main">
+  <p:cSld>
+    <p:spTree>
+      <p:nvGrpSpPr>
+        <p:cNvPr id="1" name=""/>
+        <p:cNvGrpSpPr/>
+        <p:nvPr/>
+      </p:nvGrpSpPr>
+      <p:grpSpPr>
+        <a:xfrm>
+          <a:off x="0" y="0"/>
+          <a:ext cx="0" cy="0"/>
+          <a:chOff x="0" y="0"/>
+          <a:chExt cx="0" cy="0"/>
+        </a:xfrm>
+      </p:grpSpPr>
+      <p:sp>
+        <p:nvSpPr>
+          <p:cNvPr id="2" name="Cím 1">
+            <a:extLst>
+              <a:ext uri="{FF2B5EF4-FFF2-40B4-BE49-F238E27FC236}">
+                <a16:creationId xmlns:a16="http://schemas.microsoft.com/office/drawing/2014/main" id="{D6469646-26F7-4751-929B-858BDD220370}"/>
+              </a:ext>
+            </a:extLst>
+          </p:cNvPr>
+          <p:cNvSpPr>
+            <a:spLocks noGrp="1"/>
+          </p:cNvSpPr>
+          <p:nvPr>
+            <p:ph type="title"/>
+          </p:nvPr>
+        </p:nvSpPr>
+        <p:spPr>
+          <a:xfrm>
+            <a:off x="2976562" y="2766218"/>
+            <a:ext cx="6238875" cy="1325563"/>
+          </a:xfrm>
+        </p:spPr>
+        <p:txBody>
+          <a:bodyPr/>
+          <a:lstStyle/>
+          <a:p>
+            <a:pPr algn="ctr"/>
+            <a:r>
+              <a:rPr lang="hu-HU" dirty="0">
+                <a:solidFill>
+                  <a:schemeClr val="tx1">
+                    <a:lumMod val="95000"/>
+                    <a:lumOff val="5000"/>
+                  </a:schemeClr>
+                </a:solidFill>
+                <a:latin typeface="Arial Black" panose="020B0A04020102020204" pitchFamily="34" charset="0"/>
+              </a:rPr>
+              <a:t>Köszönjük a figyelmet</a:t>
+            </a:r>
+          </a:p>
+        </p:txBody>
+      </p:sp>
+    </p:spTree>
+    <p:extLst>
+      <p:ext uri="{BB962C8B-B14F-4D97-AF65-F5344CB8AC3E}">
+        <p14:creationId xmlns:p14="http://schemas.microsoft.com/office/powerpoint/2010/main" val="3700418031"/>
+      </p:ext>
+    </p:extLst>
+  </p:cSld>
+  <p:clrMapOvr>
+    <a:masterClrMapping/>
+  </p:clrMapOvr>
+</p:sld>
+</file>
+
 <file path=ppt/slides/slide2.xml><?xml version="1.0" encoding="utf-8"?>
 <p:sld xmlns:a="http://schemas.openxmlformats.org/drawingml/2006/main" xmlns:r="http://schemas.openxmlformats.org/officeDocument/2006/relationships" xmlns:p="http://schemas.openxmlformats.org/presentationml/2006/main">
   <p:cSld>
@@ -3963,6 +4831,322 @@
           <p:cNvPr id="2" name="Cím 1">
             <a:extLst>
               <a:ext uri="{FF2B5EF4-FFF2-40B4-BE49-F238E27FC236}">
+                <a16:creationId xmlns:a16="http://schemas.microsoft.com/office/drawing/2014/main" id="{79DAFD88-C4EE-451F-9072-AF08B74ABAC9}"/>
+              </a:ext>
+            </a:extLst>
+          </p:cNvPr>
+          <p:cNvSpPr>
+            <a:spLocks noGrp="1"/>
+          </p:cNvSpPr>
+          <p:nvPr>
+            <p:ph type="title"/>
+          </p:nvPr>
+        </p:nvSpPr>
+        <p:spPr/>
+        <p:txBody>
+          <a:bodyPr/>
+          <a:lstStyle/>
+          <a:p>
+            <a:r>
+              <a:rPr lang="hu-HU" dirty="0">
+                <a:solidFill>
+                  <a:schemeClr val="bg1"/>
+                </a:solidFill>
+                <a:latin typeface="Arial Black" panose="020B0A04020102020204" pitchFamily="34" charset="0"/>
+              </a:rPr>
+              <a:t>Használt technológiák</a:t>
+            </a:r>
+          </a:p>
+        </p:txBody>
+      </p:sp>
+      <p:sp>
+        <p:nvSpPr>
+          <p:cNvPr id="3" name="Tartalom helye 2">
+            <a:extLst>
+              <a:ext uri="{FF2B5EF4-FFF2-40B4-BE49-F238E27FC236}">
+                <a16:creationId xmlns:a16="http://schemas.microsoft.com/office/drawing/2014/main" id="{08EA1836-9275-4F9A-B38E-AFCDE699BA3D}"/>
+              </a:ext>
+            </a:extLst>
+          </p:cNvPr>
+          <p:cNvSpPr>
+            <a:spLocks noGrp="1"/>
+          </p:cNvSpPr>
+          <p:nvPr>
+            <p:ph idx="1"/>
+          </p:nvPr>
+        </p:nvSpPr>
+        <p:spPr/>
+        <p:txBody>
+          <a:bodyPr/>
+          <a:lstStyle/>
+          <a:p>
+            <a:r>
+              <a:rPr lang="hu-HU" dirty="0">
+                <a:latin typeface="Arial Black" panose="020B0A04020102020204" pitchFamily="34" charset="0"/>
+              </a:rPr>
+              <a:t>ESP-IDF</a:t>
+            </a:r>
+          </a:p>
+          <a:p>
+            <a:pPr lvl="1"/>
+            <a:r>
+              <a:rPr lang="hu-HU" dirty="0">
+                <a:latin typeface="Arial Black" panose="020B0A04020102020204" pitchFamily="34" charset="0"/>
+              </a:rPr>
+              <a:t>ESP fejlesztői környezet</a:t>
+            </a:r>
+          </a:p>
+          <a:p>
+            <a:pPr lvl="1"/>
+            <a:r>
+              <a:rPr lang="hu-HU" dirty="0">
+                <a:latin typeface="Arial Black" panose="020B0A04020102020204" pitchFamily="34" charset="0"/>
+              </a:rPr>
+              <a:t>Alkalmazás vagy VS </a:t>
+            </a:r>
+            <a:r>
+              <a:rPr lang="hu-HU" dirty="0" err="1">
+                <a:latin typeface="Arial Black" panose="020B0A04020102020204" pitchFamily="34" charset="0"/>
+              </a:rPr>
+              <a:t>Code</a:t>
+            </a:r>
+            <a:r>
+              <a:rPr lang="hu-HU" dirty="0">
+                <a:latin typeface="Arial Black" panose="020B0A04020102020204" pitchFamily="34" charset="0"/>
+              </a:rPr>
+              <a:t> bővítmény</a:t>
+            </a:r>
+          </a:p>
+          <a:p>
+            <a:r>
+              <a:rPr lang="hu-HU" dirty="0">
+                <a:latin typeface="Arial Black" panose="020B0A04020102020204" pitchFamily="34" charset="0"/>
+              </a:rPr>
+              <a:t>VS </a:t>
+            </a:r>
+            <a:r>
+              <a:rPr lang="hu-HU" dirty="0" err="1">
+                <a:latin typeface="Arial Black" panose="020B0A04020102020204" pitchFamily="34" charset="0"/>
+              </a:rPr>
+              <a:t>Code</a:t>
+            </a:r>
+            <a:endParaRPr lang="hu-HU" dirty="0">
+              <a:latin typeface="Arial Black" panose="020B0A04020102020204" pitchFamily="34" charset="0"/>
+            </a:endParaRPr>
+          </a:p>
+          <a:p>
+            <a:pPr lvl="1"/>
+            <a:r>
+              <a:rPr lang="hu-HU" dirty="0">
+                <a:latin typeface="Arial Black" panose="020B0A04020102020204" pitchFamily="34" charset="0"/>
+              </a:rPr>
+              <a:t>Program szerkesztés</a:t>
+            </a:r>
+          </a:p>
+          <a:p>
+            <a:r>
+              <a:rPr lang="hu-HU" dirty="0" err="1">
+                <a:latin typeface="Arial Black" panose="020B0A04020102020204" pitchFamily="34" charset="0"/>
+              </a:rPr>
+              <a:t>Supabase</a:t>
+            </a:r>
+            <a:endParaRPr lang="hu-HU" dirty="0">
+              <a:latin typeface="Arial Black" panose="020B0A04020102020204" pitchFamily="34" charset="0"/>
+            </a:endParaRPr>
+          </a:p>
+          <a:p>
+            <a:pPr lvl="1"/>
+            <a:r>
+              <a:rPr lang="hu-HU" dirty="0">
+                <a:latin typeface="Arial Black" panose="020B0A04020102020204" pitchFamily="34" charset="0"/>
+              </a:rPr>
+              <a:t>Online adatbázis</a:t>
+            </a:r>
+          </a:p>
+        </p:txBody>
+      </p:sp>
+      <p:pic>
+        <p:nvPicPr>
+          <p:cNvPr id="1026" name="Picture 2" descr="Getting Started With ESP-IDF | Set Up Espressif IDE – RoboticWorx">
+            <a:extLst>
+              <a:ext uri="{FF2B5EF4-FFF2-40B4-BE49-F238E27FC236}">
+                <a16:creationId xmlns:a16="http://schemas.microsoft.com/office/drawing/2014/main" id="{E99DB11A-8850-412C-B4EE-A36F0F48EB4C}"/>
+              </a:ext>
+            </a:extLst>
+          </p:cNvPr>
+          <p:cNvPicPr>
+            <a:picLocks noChangeAspect="1" noChangeArrowheads="1"/>
+          </p:cNvPicPr>
+          <p:nvPr/>
+        </p:nvPicPr>
+        <p:blipFill>
+          <a:blip r:embed="rId2">
+            <a:extLst>
+              <a:ext uri="{28A0092B-C50C-407E-A947-70E740481C1C}">
+                <a14:useLocalDpi xmlns:a14="http://schemas.microsoft.com/office/drawing/2010/main" val="0"/>
+              </a:ext>
+            </a:extLst>
+          </a:blip>
+          <a:srcRect/>
+          <a:stretch>
+            <a:fillRect/>
+          </a:stretch>
+        </p:blipFill>
+        <p:spPr bwMode="auto">
+          <a:xfrm>
+            <a:off x="8229600" y="1332708"/>
+            <a:ext cx="2046092" cy="1471612"/>
+          </a:xfrm>
+          <a:prstGeom prst="rect">
+            <a:avLst/>
+          </a:prstGeom>
+          <a:noFill/>
+          <a:effectLst>
+            <a:softEdge rad="63500"/>
+          </a:effectLst>
+          <a:extLst>
+            <a:ext uri="{909E8E84-426E-40DD-AFC4-6F175D3DCCD1}">
+              <a14:hiddenFill xmlns:a14="http://schemas.microsoft.com/office/drawing/2010/main">
+                <a:solidFill>
+                  <a:srgbClr val="FFFFFF"/>
+                </a:solidFill>
+              </a14:hiddenFill>
+            </a:ext>
+          </a:extLst>
+        </p:spPr>
+      </p:pic>
+      <p:pic>
+        <p:nvPicPr>
+          <p:cNvPr id="1028" name="Picture 4" descr="Visual Studio Code használata 2. rész">
+            <a:extLst>
+              <a:ext uri="{FF2B5EF4-FFF2-40B4-BE49-F238E27FC236}">
+                <a16:creationId xmlns:a16="http://schemas.microsoft.com/office/drawing/2014/main" id="{0A4C2EAE-3980-4EED-BC11-CF2201FCF7D8}"/>
+              </a:ext>
+            </a:extLst>
+          </p:cNvPr>
+          <p:cNvPicPr>
+            <a:picLocks noChangeAspect="1" noChangeArrowheads="1"/>
+          </p:cNvPicPr>
+          <p:nvPr/>
+        </p:nvPicPr>
+        <p:blipFill>
+          <a:blip r:embed="rId3">
+            <a:extLst>
+              <a:ext uri="{28A0092B-C50C-407E-A947-70E740481C1C}">
+                <a14:useLocalDpi xmlns:a14="http://schemas.microsoft.com/office/drawing/2010/main" val="0"/>
+              </a:ext>
+            </a:extLst>
+          </a:blip>
+          <a:srcRect/>
+          <a:stretch>
+            <a:fillRect/>
+          </a:stretch>
+        </p:blipFill>
+        <p:spPr bwMode="auto">
+          <a:xfrm>
+            <a:off x="8609264" y="3297237"/>
+            <a:ext cx="2124075" cy="2124075"/>
+          </a:xfrm>
+          <a:prstGeom prst="rect">
+            <a:avLst/>
+          </a:prstGeom>
+          <a:noFill/>
+          <a:extLst>
+            <a:ext uri="{909E8E84-426E-40DD-AFC4-6F175D3DCCD1}">
+              <a14:hiddenFill xmlns:a14="http://schemas.microsoft.com/office/drawing/2010/main">
+                <a:solidFill>
+                  <a:srgbClr val="FFFFFF"/>
+                </a:solidFill>
+              </a14:hiddenFill>
+            </a:ext>
+          </a:extLst>
+        </p:spPr>
+      </p:pic>
+      <p:pic>
+        <p:nvPicPr>
+          <p:cNvPr id="1030" name="Picture 6" descr="Deploy Supabase">
+            <a:extLst>
+              <a:ext uri="{FF2B5EF4-FFF2-40B4-BE49-F238E27FC236}">
+                <a16:creationId xmlns:a16="http://schemas.microsoft.com/office/drawing/2014/main" id="{95048B5D-A32F-4898-AEA9-14E998460E87}"/>
+              </a:ext>
+            </a:extLst>
+          </p:cNvPr>
+          <p:cNvPicPr>
+            <a:picLocks noChangeAspect="1" noChangeArrowheads="1"/>
+          </p:cNvPicPr>
+          <p:nvPr/>
+        </p:nvPicPr>
+        <p:blipFill>
+          <a:blip r:embed="rId4">
+            <a:extLst>
+              <a:ext uri="{28A0092B-C50C-407E-A947-70E740481C1C}">
+                <a14:useLocalDpi xmlns:a14="http://schemas.microsoft.com/office/drawing/2010/main" val="0"/>
+              </a:ext>
+            </a:extLst>
+          </a:blip>
+          <a:srcRect/>
+          <a:stretch>
+            <a:fillRect/>
+          </a:stretch>
+        </p:blipFill>
+        <p:spPr bwMode="auto">
+          <a:xfrm>
+            <a:off x="5776467" y="4492625"/>
+            <a:ext cx="2000250" cy="2000250"/>
+          </a:xfrm>
+          <a:prstGeom prst="rect">
+            <a:avLst/>
+          </a:prstGeom>
+          <a:noFill/>
+          <a:effectLst>
+            <a:softEdge rad="63500"/>
+          </a:effectLst>
+          <a:extLst>
+            <a:ext uri="{909E8E84-426E-40DD-AFC4-6F175D3DCCD1}">
+              <a14:hiddenFill xmlns:a14="http://schemas.microsoft.com/office/drawing/2010/main">
+                <a:solidFill>
+                  <a:srgbClr val="FFFFFF"/>
+                </a:solidFill>
+              </a14:hiddenFill>
+            </a:ext>
+          </a:extLst>
+        </p:spPr>
+      </p:pic>
+    </p:spTree>
+    <p:extLst>
+      <p:ext uri="{BB962C8B-B14F-4D97-AF65-F5344CB8AC3E}">
+        <p14:creationId xmlns:p14="http://schemas.microsoft.com/office/powerpoint/2010/main" val="1082755436"/>
+      </p:ext>
+    </p:extLst>
+  </p:cSld>
+  <p:clrMapOvr>
+    <a:masterClrMapping/>
+  </p:clrMapOvr>
+</p:sld>
+</file>
+
+<file path=ppt/slides/slide4.xml><?xml version="1.0" encoding="utf-8"?>
+<p:sld xmlns:a="http://schemas.openxmlformats.org/drawingml/2006/main" xmlns:r="http://schemas.openxmlformats.org/officeDocument/2006/relationships" xmlns:p="http://schemas.openxmlformats.org/presentationml/2006/main">
+  <p:cSld>
+    <p:spTree>
+      <p:nvGrpSpPr>
+        <p:cNvPr id="1" name=""/>
+        <p:cNvGrpSpPr/>
+        <p:nvPr/>
+      </p:nvGrpSpPr>
+      <p:grpSpPr>
+        <a:xfrm>
+          <a:off x="0" y="0"/>
+          <a:ext cx="0" cy="0"/>
+          <a:chOff x="0" y="0"/>
+          <a:chExt cx="0" cy="0"/>
+        </a:xfrm>
+      </p:grpSpPr>
+      <p:sp>
+        <p:nvSpPr>
+          <p:cNvPr id="2" name="Cím 1">
+            <a:extLst>
+              <a:ext uri="{FF2B5EF4-FFF2-40B4-BE49-F238E27FC236}">
                 <a16:creationId xmlns:a16="http://schemas.microsoft.com/office/drawing/2014/main" id="{14AB11D9-507F-4045-A738-489D2885A066}"/>
               </a:ext>
             </a:extLst>
@@ -4173,7 +5357,7 @@
 </p:sld>
 </file>
 
-<file path=ppt/slides/slide4.xml><?xml version="1.0" encoding="utf-8"?>
+<file path=ppt/slides/slide5.xml><?xml version="1.0" encoding="utf-8"?>
 <p:sld xmlns:a="http://schemas.openxmlformats.org/drawingml/2006/main" xmlns:r="http://schemas.openxmlformats.org/officeDocument/2006/relationships" xmlns:p="http://schemas.openxmlformats.org/presentationml/2006/main">
   <p:cSld>
     <p:spTree>
@@ -4608,7 +5792,7 @@
 </p:sld>
 </file>
 
-<file path=ppt/slides/slide5.xml><?xml version="1.0" encoding="utf-8"?>
+<file path=ppt/slides/slide6.xml><?xml version="1.0" encoding="utf-8"?>
 <p:sld xmlns:a="http://schemas.openxmlformats.org/drawingml/2006/main" xmlns:r="http://schemas.openxmlformats.org/officeDocument/2006/relationships" xmlns:p="http://schemas.openxmlformats.org/presentationml/2006/main">
   <p:cSld>
     <p:spTree>
@@ -4679,7 +5863,7 @@
         <p:spPr>
           <a:xfrm>
             <a:off x="838200" y="1825625"/>
-            <a:ext cx="6962775" cy="4351338"/>
+            <a:ext cx="7924800" cy="4351338"/>
           </a:xfrm>
         </p:spPr>
         <p:txBody>
@@ -4768,7 +5952,7 @@
               <a:rPr lang="hu-HU" sz="1600" dirty="0">
                 <a:latin typeface="Arial Black" panose="020B0A04020102020204" pitchFamily="34" charset="0"/>
               </a:rPr>
-              <a:t>Hőmérséklet, légnyomás, páratartalom, magasság</a:t>
+              <a:t>Hőmérséklet, légnyomás, páratartalom, magasság, időbélyeg</a:t>
             </a:r>
           </a:p>
           <a:p>
@@ -4852,222 +6036,6 @@
 </p:sld>
 </file>
 
-<file path=ppt/slides/slide6.xml><?xml version="1.0" encoding="utf-8"?>
-<p:sld xmlns:a="http://schemas.openxmlformats.org/drawingml/2006/main" xmlns:r="http://schemas.openxmlformats.org/officeDocument/2006/relationships" xmlns:p="http://schemas.openxmlformats.org/presentationml/2006/main">
-  <p:cSld>
-    <p:spTree>
-      <p:nvGrpSpPr>
-        <p:cNvPr id="1" name=""/>
-        <p:cNvGrpSpPr/>
-        <p:nvPr/>
-      </p:nvGrpSpPr>
-      <p:grpSpPr>
-        <a:xfrm>
-          <a:off x="0" y="0"/>
-          <a:ext cx="0" cy="0"/>
-          <a:chOff x="0" y="0"/>
-          <a:chExt cx="0" cy="0"/>
-        </a:xfrm>
-      </p:grpSpPr>
-      <p:sp>
-        <p:nvSpPr>
-          <p:cNvPr id="2" name="Cím 1">
-            <a:extLst>
-              <a:ext uri="{FF2B5EF4-FFF2-40B4-BE49-F238E27FC236}">
-                <a16:creationId xmlns:a16="http://schemas.microsoft.com/office/drawing/2014/main" id="{1AD1C67B-8E7B-424B-AF32-22B5AA0D014D}"/>
-              </a:ext>
-            </a:extLst>
-          </p:cNvPr>
-          <p:cNvSpPr>
-            <a:spLocks noGrp="1"/>
-          </p:cNvSpPr>
-          <p:nvPr>
-            <p:ph type="title"/>
-          </p:nvPr>
-        </p:nvSpPr>
-        <p:spPr/>
-        <p:txBody>
-          <a:bodyPr/>
-          <a:lstStyle/>
-          <a:p>
-            <a:r>
-              <a:rPr lang="hu-HU" dirty="0">
-                <a:solidFill>
-                  <a:schemeClr val="bg1"/>
-                </a:solidFill>
-                <a:latin typeface="Arial Black" panose="020B0A04020102020204" pitchFamily="34" charset="0"/>
-              </a:rPr>
-              <a:t>Idő és dátum</a:t>
-            </a:r>
-          </a:p>
-        </p:txBody>
-      </p:sp>
-      <p:sp>
-        <p:nvSpPr>
-          <p:cNvPr id="3" name="Tartalom helye 2">
-            <a:extLst>
-              <a:ext uri="{FF2B5EF4-FFF2-40B4-BE49-F238E27FC236}">
-                <a16:creationId xmlns:a16="http://schemas.microsoft.com/office/drawing/2014/main" id="{167CBC41-1E22-4543-BF7B-7EAEC5A2859D}"/>
-              </a:ext>
-            </a:extLst>
-          </p:cNvPr>
-          <p:cNvSpPr>
-            <a:spLocks noGrp="1"/>
-          </p:cNvSpPr>
-          <p:nvPr>
-            <p:ph idx="1"/>
-          </p:nvPr>
-        </p:nvSpPr>
-        <p:spPr/>
-        <p:txBody>
-          <a:bodyPr/>
-          <a:lstStyle/>
-          <a:p>
-            <a:pPr>
-              <a:spcBef>
-                <a:spcPts val="1200"/>
-              </a:spcBef>
-              <a:spcAft>
-                <a:spcPts val="1200"/>
-              </a:spcAft>
-            </a:pPr>
-            <a:r>
-              <a:rPr lang="hu-HU" dirty="0">
-                <a:latin typeface="Arial Black" panose="020B0A04020102020204" pitchFamily="34" charset="0"/>
-              </a:rPr>
-              <a:t>A méréseket időben is el kell helyezni</a:t>
-            </a:r>
-          </a:p>
-          <a:p>
-            <a:pPr>
-              <a:spcBef>
-                <a:spcPts val="1200"/>
-              </a:spcBef>
-              <a:spcAft>
-                <a:spcPts val="1200"/>
-              </a:spcAft>
-            </a:pPr>
-            <a:r>
-              <a:rPr lang="hu-HU" dirty="0">
-                <a:latin typeface="Arial Black" panose="020B0A04020102020204" pitchFamily="34" charset="0"/>
-              </a:rPr>
-              <a:t>Mi most az idő és dátum ?</a:t>
-            </a:r>
-          </a:p>
-          <a:p>
-            <a:pPr>
-              <a:spcBef>
-                <a:spcPts val="1200"/>
-              </a:spcBef>
-              <a:spcAft>
-                <a:spcPts val="1200"/>
-              </a:spcAft>
-            </a:pPr>
-            <a:r>
-              <a:rPr lang="hu-HU" dirty="0">
-                <a:latin typeface="Arial Black" panose="020B0A04020102020204" pitchFamily="34" charset="0"/>
-              </a:rPr>
-              <a:t>Az idő és dátum lekérése wifi csatlakozás esetén</a:t>
-            </a:r>
-          </a:p>
-          <a:p>
-            <a:pPr>
-              <a:spcBef>
-                <a:spcPts val="1200"/>
-              </a:spcBef>
-              <a:spcAft>
-                <a:spcPts val="1200"/>
-              </a:spcAft>
-            </a:pPr>
-            <a:r>
-              <a:rPr lang="hu-HU" dirty="0">
-                <a:latin typeface="Arial Black" panose="020B0A04020102020204" pitchFamily="34" charset="0"/>
-              </a:rPr>
-              <a:t>Mérés ha nincs pontos idő ?</a:t>
-            </a:r>
-          </a:p>
-          <a:p>
-            <a:pPr>
-              <a:spcBef>
-                <a:spcPts val="1200"/>
-              </a:spcBef>
-              <a:spcAft>
-                <a:spcPts val="1200"/>
-              </a:spcAft>
-            </a:pPr>
-            <a:r>
-              <a:rPr lang="hu-HU" dirty="0">
-                <a:latin typeface="Arial Black" panose="020B0A04020102020204" pitchFamily="34" charset="0"/>
-              </a:rPr>
-              <a:t>Time </a:t>
-            </a:r>
-            <a:r>
-              <a:rPr lang="hu-HU" dirty="0" err="1">
-                <a:latin typeface="Arial Black" panose="020B0A04020102020204" pitchFamily="34" charset="0"/>
-              </a:rPr>
-              <a:t>Drift</a:t>
-            </a:r>
-            <a:r>
-              <a:rPr lang="hu-HU" dirty="0">
-                <a:latin typeface="Arial Black" panose="020B0A04020102020204" pitchFamily="34" charset="0"/>
-              </a:rPr>
-              <a:t> ( idő elcsúszása )</a:t>
-            </a:r>
-          </a:p>
-          <a:p>
-            <a:pPr>
-              <a:spcBef>
-                <a:spcPts val="1200"/>
-              </a:spcBef>
-              <a:spcAft>
-                <a:spcPts val="1200"/>
-              </a:spcAft>
-            </a:pPr>
-            <a:endParaRPr lang="hu-HU" dirty="0">
-              <a:latin typeface="Arial Black" panose="020B0A04020102020204" pitchFamily="34" charset="0"/>
-            </a:endParaRPr>
-          </a:p>
-          <a:p>
-            <a:pPr>
-              <a:spcBef>
-                <a:spcPts val="1200"/>
-              </a:spcBef>
-              <a:spcAft>
-                <a:spcPts val="1200"/>
-              </a:spcAft>
-            </a:pPr>
-            <a:endParaRPr lang="hu-HU" dirty="0">
-              <a:latin typeface="Arial Black" panose="020B0A04020102020204" pitchFamily="34" charset="0"/>
-            </a:endParaRPr>
-          </a:p>
-          <a:p>
-            <a:pPr>
-              <a:spcBef>
-                <a:spcPts val="1200"/>
-              </a:spcBef>
-              <a:spcAft>
-                <a:spcPts val="1200"/>
-              </a:spcAft>
-            </a:pPr>
-            <a:endParaRPr lang="hu-HU" dirty="0">
-              <a:latin typeface="Arial Black" panose="020B0A04020102020204" pitchFamily="34" charset="0"/>
-            </a:endParaRPr>
-          </a:p>
-        </p:txBody>
-      </p:sp>
-    </p:spTree>
-    <p:extLst>
-      <p:ext uri="{BB962C8B-B14F-4D97-AF65-F5344CB8AC3E}">
-        <p14:creationId xmlns:p14="http://schemas.microsoft.com/office/powerpoint/2010/main" val="35969245"/>
-      </p:ext>
-    </p:extLst>
-  </p:cSld>
-  <p:clrMapOvr>
-    <a:masterClrMapping/>
-  </p:clrMapOvr>
-</p:sld>
-</file>
-
 <file path=ppt/slides/slide7.xml><?xml version="1.0" encoding="utf-8"?>
 <p:sld xmlns:a="http://schemas.openxmlformats.org/drawingml/2006/main" xmlns:r="http://schemas.openxmlformats.org/officeDocument/2006/relationships" xmlns:p="http://schemas.openxmlformats.org/presentationml/2006/main">
   <p:cSld>
@@ -5090,7 +6058,7 @@
           <p:cNvPr id="2" name="Cím 1">
             <a:extLst>
               <a:ext uri="{FF2B5EF4-FFF2-40B4-BE49-F238E27FC236}">
-                <a16:creationId xmlns:a16="http://schemas.microsoft.com/office/drawing/2014/main" id="{0738C47B-524A-47AA-87E1-5C2D201916AF}"/>
+                <a16:creationId xmlns:a16="http://schemas.microsoft.com/office/drawing/2014/main" id="{1AD1C67B-8E7B-424B-AF32-22B5AA0D014D}"/>
               </a:ext>
             </a:extLst>
           </p:cNvPr>
@@ -5113,6 +6081,222 @@
                 </a:solidFill>
                 <a:latin typeface="Arial Black" panose="020B0A04020102020204" pitchFamily="34" charset="0"/>
               </a:rPr>
+              <a:t>Idő és dátum</a:t>
+            </a:r>
+          </a:p>
+        </p:txBody>
+      </p:sp>
+      <p:sp>
+        <p:nvSpPr>
+          <p:cNvPr id="3" name="Tartalom helye 2">
+            <a:extLst>
+              <a:ext uri="{FF2B5EF4-FFF2-40B4-BE49-F238E27FC236}">
+                <a16:creationId xmlns:a16="http://schemas.microsoft.com/office/drawing/2014/main" id="{167CBC41-1E22-4543-BF7B-7EAEC5A2859D}"/>
+              </a:ext>
+            </a:extLst>
+          </p:cNvPr>
+          <p:cNvSpPr>
+            <a:spLocks noGrp="1"/>
+          </p:cNvSpPr>
+          <p:nvPr>
+            <p:ph idx="1"/>
+          </p:nvPr>
+        </p:nvSpPr>
+        <p:spPr/>
+        <p:txBody>
+          <a:bodyPr/>
+          <a:lstStyle/>
+          <a:p>
+            <a:pPr>
+              <a:spcBef>
+                <a:spcPts val="1200"/>
+              </a:spcBef>
+              <a:spcAft>
+                <a:spcPts val="1200"/>
+              </a:spcAft>
+            </a:pPr>
+            <a:r>
+              <a:rPr lang="hu-HU" dirty="0">
+                <a:latin typeface="Arial Black" panose="020B0A04020102020204" pitchFamily="34" charset="0"/>
+              </a:rPr>
+              <a:t>A méréseket időben is el kell helyezni</a:t>
+            </a:r>
+          </a:p>
+          <a:p>
+            <a:pPr>
+              <a:spcBef>
+                <a:spcPts val="1200"/>
+              </a:spcBef>
+              <a:spcAft>
+                <a:spcPts val="1200"/>
+              </a:spcAft>
+            </a:pPr>
+            <a:r>
+              <a:rPr lang="hu-HU" dirty="0">
+                <a:latin typeface="Arial Black" panose="020B0A04020102020204" pitchFamily="34" charset="0"/>
+              </a:rPr>
+              <a:t>Most mennyi az idő és mi a dátum ?</a:t>
+            </a:r>
+          </a:p>
+          <a:p>
+            <a:pPr>
+              <a:spcBef>
+                <a:spcPts val="1200"/>
+              </a:spcBef>
+              <a:spcAft>
+                <a:spcPts val="1200"/>
+              </a:spcAft>
+            </a:pPr>
+            <a:r>
+              <a:rPr lang="hu-HU" dirty="0">
+                <a:latin typeface="Arial Black" panose="020B0A04020102020204" pitchFamily="34" charset="0"/>
+              </a:rPr>
+              <a:t>Az idő és dátum lekérése wifi csatlakozás esetén</a:t>
+            </a:r>
+          </a:p>
+          <a:p>
+            <a:pPr>
+              <a:spcBef>
+                <a:spcPts val="1200"/>
+              </a:spcBef>
+              <a:spcAft>
+                <a:spcPts val="1200"/>
+              </a:spcAft>
+            </a:pPr>
+            <a:r>
+              <a:rPr lang="hu-HU" dirty="0">
+                <a:latin typeface="Arial Black" panose="020B0A04020102020204" pitchFamily="34" charset="0"/>
+              </a:rPr>
+              <a:t>Mérés ha nincs pontos idő ?</a:t>
+            </a:r>
+          </a:p>
+          <a:p>
+            <a:pPr>
+              <a:spcBef>
+                <a:spcPts val="1200"/>
+              </a:spcBef>
+              <a:spcAft>
+                <a:spcPts val="1200"/>
+              </a:spcAft>
+            </a:pPr>
+            <a:r>
+              <a:rPr lang="hu-HU" dirty="0">
+                <a:latin typeface="Arial Black" panose="020B0A04020102020204" pitchFamily="34" charset="0"/>
+              </a:rPr>
+              <a:t>Time </a:t>
+            </a:r>
+            <a:r>
+              <a:rPr lang="hu-HU" dirty="0" err="1">
+                <a:latin typeface="Arial Black" panose="020B0A04020102020204" pitchFamily="34" charset="0"/>
+              </a:rPr>
+              <a:t>Drift</a:t>
+            </a:r>
+            <a:r>
+              <a:rPr lang="hu-HU" dirty="0">
+                <a:latin typeface="Arial Black" panose="020B0A04020102020204" pitchFamily="34" charset="0"/>
+              </a:rPr>
+              <a:t> ( idő elcsúszása )</a:t>
+            </a:r>
+          </a:p>
+          <a:p>
+            <a:pPr>
+              <a:spcBef>
+                <a:spcPts val="1200"/>
+              </a:spcBef>
+              <a:spcAft>
+                <a:spcPts val="1200"/>
+              </a:spcAft>
+            </a:pPr>
+            <a:endParaRPr lang="hu-HU" dirty="0">
+              <a:latin typeface="Arial Black" panose="020B0A04020102020204" pitchFamily="34" charset="0"/>
+            </a:endParaRPr>
+          </a:p>
+          <a:p>
+            <a:pPr>
+              <a:spcBef>
+                <a:spcPts val="1200"/>
+              </a:spcBef>
+              <a:spcAft>
+                <a:spcPts val="1200"/>
+              </a:spcAft>
+            </a:pPr>
+            <a:endParaRPr lang="hu-HU" dirty="0">
+              <a:latin typeface="Arial Black" panose="020B0A04020102020204" pitchFamily="34" charset="0"/>
+            </a:endParaRPr>
+          </a:p>
+          <a:p>
+            <a:pPr>
+              <a:spcBef>
+                <a:spcPts val="1200"/>
+              </a:spcBef>
+              <a:spcAft>
+                <a:spcPts val="1200"/>
+              </a:spcAft>
+            </a:pPr>
+            <a:endParaRPr lang="hu-HU" dirty="0">
+              <a:latin typeface="Arial Black" panose="020B0A04020102020204" pitchFamily="34" charset="0"/>
+            </a:endParaRPr>
+          </a:p>
+        </p:txBody>
+      </p:sp>
+    </p:spTree>
+    <p:extLst>
+      <p:ext uri="{BB962C8B-B14F-4D97-AF65-F5344CB8AC3E}">
+        <p14:creationId xmlns:p14="http://schemas.microsoft.com/office/powerpoint/2010/main" val="35969245"/>
+      </p:ext>
+    </p:extLst>
+  </p:cSld>
+  <p:clrMapOvr>
+    <a:masterClrMapping/>
+  </p:clrMapOvr>
+</p:sld>
+</file>
+
+<file path=ppt/slides/slide8.xml><?xml version="1.0" encoding="utf-8"?>
+<p:sld xmlns:a="http://schemas.openxmlformats.org/drawingml/2006/main" xmlns:r="http://schemas.openxmlformats.org/officeDocument/2006/relationships" xmlns:p="http://schemas.openxmlformats.org/presentationml/2006/main">
+  <p:cSld>
+    <p:spTree>
+      <p:nvGrpSpPr>
+        <p:cNvPr id="1" name=""/>
+        <p:cNvGrpSpPr/>
+        <p:nvPr/>
+      </p:nvGrpSpPr>
+      <p:grpSpPr>
+        <a:xfrm>
+          <a:off x="0" y="0"/>
+          <a:ext cx="0" cy="0"/>
+          <a:chOff x="0" y="0"/>
+          <a:chExt cx="0" cy="0"/>
+        </a:xfrm>
+      </p:grpSpPr>
+      <p:sp>
+        <p:nvSpPr>
+          <p:cNvPr id="2" name="Cím 1">
+            <a:extLst>
+              <a:ext uri="{FF2B5EF4-FFF2-40B4-BE49-F238E27FC236}">
+                <a16:creationId xmlns:a16="http://schemas.microsoft.com/office/drawing/2014/main" id="{0738C47B-524A-47AA-87E1-5C2D201916AF}"/>
+              </a:ext>
+            </a:extLst>
+          </p:cNvPr>
+          <p:cNvSpPr>
+            <a:spLocks noGrp="1"/>
+          </p:cNvSpPr>
+          <p:nvPr>
+            <p:ph type="title"/>
+          </p:nvPr>
+        </p:nvSpPr>
+        <p:spPr/>
+        <p:txBody>
+          <a:bodyPr/>
+          <a:lstStyle/>
+          <a:p>
+            <a:r>
+              <a:rPr lang="hu-HU" dirty="0">
+                <a:solidFill>
+                  <a:schemeClr val="bg1"/>
+                </a:solidFill>
+                <a:latin typeface="Arial Black" panose="020B0A04020102020204" pitchFamily="34" charset="0"/>
+              </a:rPr>
               <a:t>Alvás - felkeltés</a:t>
             </a:r>
           </a:p>
@@ -5137,7 +6321,7 @@
         <p:spPr>
           <a:xfrm>
             <a:off x="838200" y="1825625"/>
-            <a:ext cx="7762875" cy="4351338"/>
+            <a:ext cx="7867650" cy="4351338"/>
           </a:xfrm>
         </p:spPr>
         <p:txBody>
@@ -5205,6 +6389,170 @@
     <p:extLst>
       <p:ext uri="{BB962C8B-B14F-4D97-AF65-F5344CB8AC3E}">
         <p14:creationId xmlns:p14="http://schemas.microsoft.com/office/powerpoint/2010/main" val="2698235169"/>
+      </p:ext>
+    </p:extLst>
+  </p:cSld>
+  <p:clrMapOvr>
+    <a:masterClrMapping/>
+  </p:clrMapOvr>
+</p:sld>
+</file>
+
+<file path=ppt/slides/slide9.xml><?xml version="1.0" encoding="utf-8"?>
+<p:sld xmlns:a="http://schemas.openxmlformats.org/drawingml/2006/main" xmlns:r="http://schemas.openxmlformats.org/officeDocument/2006/relationships" xmlns:p="http://schemas.openxmlformats.org/presentationml/2006/main">
+  <p:cSld>
+    <p:spTree>
+      <p:nvGrpSpPr>
+        <p:cNvPr id="1" name=""/>
+        <p:cNvGrpSpPr/>
+        <p:nvPr/>
+      </p:nvGrpSpPr>
+      <p:grpSpPr>
+        <a:xfrm>
+          <a:off x="0" y="0"/>
+          <a:ext cx="0" cy="0"/>
+          <a:chOff x="0" y="0"/>
+          <a:chExt cx="0" cy="0"/>
+        </a:xfrm>
+      </p:grpSpPr>
+      <p:sp>
+        <p:nvSpPr>
+          <p:cNvPr id="2" name="Cím 1">
+            <a:extLst>
+              <a:ext uri="{FF2B5EF4-FFF2-40B4-BE49-F238E27FC236}">
+                <a16:creationId xmlns:a16="http://schemas.microsoft.com/office/drawing/2014/main" id="{6C6A8FA0-6834-49F2-A622-AA9AF35A10BB}"/>
+              </a:ext>
+            </a:extLst>
+          </p:cNvPr>
+          <p:cNvSpPr>
+            <a:spLocks noGrp="1"/>
+          </p:cNvSpPr>
+          <p:nvPr>
+            <p:ph type="title"/>
+          </p:nvPr>
+        </p:nvSpPr>
+        <p:spPr/>
+        <p:txBody>
+          <a:bodyPr/>
+          <a:lstStyle/>
+          <a:p>
+            <a:r>
+              <a:rPr lang="hu-HU" dirty="0">
+                <a:solidFill>
+                  <a:schemeClr val="bg1"/>
+                </a:solidFill>
+                <a:latin typeface="Arial Black" panose="020B0A04020102020204" pitchFamily="34" charset="0"/>
+              </a:rPr>
+              <a:t>Adatok megtekintése</a:t>
+            </a:r>
+          </a:p>
+        </p:txBody>
+      </p:sp>
+      <p:sp>
+        <p:nvSpPr>
+          <p:cNvPr id="3" name="Tartalom helye 2">
+            <a:extLst>
+              <a:ext uri="{FF2B5EF4-FFF2-40B4-BE49-F238E27FC236}">
+                <a16:creationId xmlns:a16="http://schemas.microsoft.com/office/drawing/2014/main" id="{125EEC3B-25A7-4DCA-8127-C588DDD76735}"/>
+              </a:ext>
+            </a:extLst>
+          </p:cNvPr>
+          <p:cNvSpPr>
+            <a:spLocks noGrp="1"/>
+          </p:cNvSpPr>
+          <p:nvPr>
+            <p:ph idx="1"/>
+          </p:nvPr>
+        </p:nvSpPr>
+        <p:spPr/>
+        <p:txBody>
+          <a:bodyPr/>
+          <a:lstStyle/>
+          <a:p>
+            <a:r>
+              <a:rPr lang="hu-HU" b="1" dirty="0">
+                <a:latin typeface="Arial Black" panose="020B0A04020102020204" pitchFamily="34" charset="0"/>
+              </a:rPr>
+              <a:t>Egyszerű weboldal az adatok megtekintésére</a:t>
+            </a:r>
+          </a:p>
+          <a:p>
+            <a:endParaRPr lang="hu-HU" b="1" dirty="0">
+              <a:latin typeface="Arial Black" panose="020B0A04020102020204" pitchFamily="34" charset="0"/>
+            </a:endParaRPr>
+          </a:p>
+        </p:txBody>
+      </p:sp>
+      <p:pic>
+        <p:nvPicPr>
+          <p:cNvPr id="4" name="Kép 3">
+            <a:extLst>
+              <a:ext uri="{FF2B5EF4-FFF2-40B4-BE49-F238E27FC236}">
+                <a16:creationId xmlns:a16="http://schemas.microsoft.com/office/drawing/2014/main" id="{BF64EDA1-393E-4B4F-A1AC-838C1E5AEF39}"/>
+              </a:ext>
+            </a:extLst>
+          </p:cNvPr>
+          <p:cNvPicPr>
+            <a:picLocks noChangeAspect="1"/>
+          </p:cNvPicPr>
+          <p:nvPr/>
+        </p:nvPicPr>
+        <p:blipFill>
+          <a:blip r:embed="rId2"/>
+          <a:stretch>
+            <a:fillRect/>
+          </a:stretch>
+        </p:blipFill>
+        <p:spPr>
+          <a:xfrm>
+            <a:off x="438150" y="2391573"/>
+            <a:ext cx="5462667" cy="2734202"/>
+          </a:xfrm>
+          <a:prstGeom prst="rect">
+            <a:avLst/>
+          </a:prstGeom>
+          <a:effectLst>
+            <a:softEdge rad="76200"/>
+          </a:effectLst>
+        </p:spPr>
+      </p:pic>
+      <p:pic>
+        <p:nvPicPr>
+          <p:cNvPr id="5" name="Kép 4">
+            <a:extLst>
+              <a:ext uri="{FF2B5EF4-FFF2-40B4-BE49-F238E27FC236}">
+                <a16:creationId xmlns:a16="http://schemas.microsoft.com/office/drawing/2014/main" id="{7429923D-01B8-413F-89C3-9DCFFFC24B5B}"/>
+              </a:ext>
+            </a:extLst>
+          </p:cNvPr>
+          <p:cNvPicPr>
+            <a:picLocks noChangeAspect="1"/>
+          </p:cNvPicPr>
+          <p:nvPr/>
+        </p:nvPicPr>
+        <p:blipFill>
+          <a:blip r:embed="rId3"/>
+          <a:stretch>
+            <a:fillRect/>
+          </a:stretch>
+        </p:blipFill>
+        <p:spPr>
+          <a:xfrm>
+            <a:off x="6010275" y="3849162"/>
+            <a:ext cx="5940860" cy="2553226"/>
+          </a:xfrm>
+          <a:prstGeom prst="rect">
+            <a:avLst/>
+          </a:prstGeom>
+          <a:effectLst>
+            <a:softEdge rad="63500"/>
+          </a:effectLst>
+        </p:spPr>
+      </p:pic>
+    </p:spTree>
+    <p:extLst>
+      <p:ext uri="{BB962C8B-B14F-4D97-AF65-F5344CB8AC3E}">
+        <p14:creationId xmlns:p14="http://schemas.microsoft.com/office/powerpoint/2010/main" val="3859560527"/>
       </p:ext>
     </p:extLst>
   </p:cSld>

</xml_diff>